<commit_message>
Fix title slides: use dark purple text on white background for readability
</commit_message>
<xml_diff>
--- a/Section_06_Correspondence_Analysis_MCA.pptx
+++ b/Section_06_Correspondence_Analysis_MCA.pptx
@@ -8,7 +8,7 @@
     <p:notesMasterId r:id="rId246"/>
   </p:notesMasterIdLst>
   <p:sldIdLst>
-    <p:sldId id="452" r:id="rId83"/>
+    <p:sldId id="965" r:id="rId72"/>
     <p:sldId id="545" r:id="rId84"/>
     <p:sldId id="726" r:id="rId85"/>
     <p:sldId id="743" r:id="rId86"/>
@@ -4369,239 +4369,6 @@
     </p:otherStyle>
   </p:txStyles>
 </p:sldMaster>
-</file>
-
-<file path=ppt/slides/slide1.xml><?xml version="1.0" encoding="utf-8"?>
-<p:sld xmlns:a="http://schemas.openxmlformats.org/drawingml/2006/main" xmlns:r="http://schemas.openxmlformats.org/officeDocument/2006/relationships" xmlns:p="http://schemas.openxmlformats.org/presentationml/2006/main">
-  <p:cSld>
-    <p:spTree>
-      <p:nvGrpSpPr>
-        <p:cNvPr id="1" name=""/>
-        <p:cNvGrpSpPr/>
-        <p:nvPr/>
-      </p:nvGrpSpPr>
-      <p:grpSpPr>
-        <a:xfrm>
-          <a:off x="0" y="0"/>
-          <a:ext cx="0" cy="0"/>
-          <a:chOff x="0" y="0"/>
-          <a:chExt cx="0" cy="0"/>
-        </a:xfrm>
-      </p:grpSpPr>
-      <p:sp>
-        <p:nvSpPr>
-          <p:cNvPr id="2" name="Title 1">
-            <a:extLst>
-              <a:ext uri="{FF2B5EF4-FFF2-40B4-BE49-F238E27FC236}">
-                <a16:creationId xmlns:a16="http://schemas.microsoft.com/office/drawing/2014/main" id="{2A14106F-A246-2E48-9544-E8146AB80CF1}"/>
-              </a:ext>
-            </a:extLst>
-          </p:cNvPr>
-          <p:cNvSpPr>
-            <a:spLocks noGrp="1"/>
-          </p:cNvSpPr>
-          <p:nvPr>
-            <p:ph type="ctrTitle"/>
-          </p:nvPr>
-        </p:nvSpPr>
-        <p:spPr>
-          <a:xfrm>
-            <a:off x="1524000" y="1122363"/>
-            <a:ext cx="9144000" cy="2387600"/>
-          </a:xfrm>
-        </p:spPr>
-        <p:txBody>
-          <a:bodyPr anchor="b"/>
-          <a:lstStyle>
-            <a:lvl1pPr algn="ctr">
-              <a:defRPr sz="6000"/>
-            </a:lvl1pPr>
-          </a:lstStyle>
-          <a:p>
-            <a:pPr algn="l"/>
-            <a:r>
-              <a:rPr lang="en-US" sz="3600" b="1">
-                <a:solidFill>
-                  <a:srgbClr val="FFFFFF"/>
-                </a:solidFill>
-                <a:latin typeface="Encode Sans"/>
-              </a:rPr>
-              <a:t>Correspondence Analysis</a:t>
-            </a:r>
-          </a:p>
-          <a:p>
-            <a:pPr algn="l"/>
-            <a:r>
-              <a:rPr lang="en-US" sz="3600" b="1">
-                <a:solidFill>
-                  <a:srgbClr val="FFFFFF"/>
-                </a:solidFill>
-                <a:latin typeface="Encode Sans"/>
-              </a:rPr>
-              <a:t>and MCA</a:t>
-            </a:r>
-          </a:p>
-        </p:txBody>
-      </p:sp>
-      <p:sp>
-        <p:nvSpPr>
-          <p:cNvPr id="3" name="Subtitle 2">
-            <a:extLst>
-              <a:ext uri="{FF2B5EF4-FFF2-40B4-BE49-F238E27FC236}">
-                <a16:creationId xmlns:a16="http://schemas.microsoft.com/office/drawing/2014/main" id="{73229C53-2CA9-764A-93AB-ECAD546B01FA}"/>
-              </a:ext>
-            </a:extLst>
-          </p:cNvPr>
-          <p:cNvSpPr>
-            <a:spLocks noGrp="1"/>
-          </p:cNvSpPr>
-          <p:nvPr>
-            <p:ph type="subTitle" idx="1"/>
-          </p:nvPr>
-        </p:nvSpPr>
-        <p:spPr>
-          <a:xfrm>
-            <a:off x="1524000" y="3602038"/>
-            <a:ext cx="9144000" cy="1655762"/>
-          </a:xfrm>
-        </p:spPr>
-        <p:txBody>
-          <a:bodyPr/>
-          <a:lstStyle>
-            <a:lvl1pPr marL="0" indent="0" algn="ctr">
-              <a:buNone/>
-              <a:defRPr sz="2400"/>
-            </a:lvl1pPr>
-            <a:lvl2pPr marL="457200" indent="0" algn="ctr">
-              <a:buNone/>
-              <a:defRPr sz="2000"/>
-            </a:lvl2pPr>
-            <a:lvl3pPr marL="914400" indent="0" algn="ctr">
-              <a:buNone/>
-              <a:defRPr sz="1800"/>
-            </a:lvl3pPr>
-            <a:lvl4pPr marL="1371600" indent="0" algn="ctr">
-              <a:buNone/>
-              <a:defRPr sz="1600"/>
-            </a:lvl4pPr>
-            <a:lvl5pPr marL="1828800" indent="0" algn="ctr">
-              <a:buNone/>
-              <a:defRPr sz="1600"/>
-            </a:lvl5pPr>
-            <a:lvl6pPr marL="2286000" indent="0" algn="ctr">
-              <a:buNone/>
-              <a:defRPr sz="1600"/>
-            </a:lvl6pPr>
-            <a:lvl7pPr marL="2743200" indent="0" algn="ctr">
-              <a:buNone/>
-              <a:defRPr sz="1600"/>
-            </a:lvl7pPr>
-            <a:lvl8pPr marL="3200400" indent="0" algn="ctr">
-              <a:buNone/>
-              <a:defRPr sz="1600"/>
-            </a:lvl8pPr>
-            <a:lvl9pPr marL="3657600" indent="0" algn="ctr">
-              <a:buNone/>
-              <a:defRPr sz="1600"/>
-            </a:lvl9pPr>
-          </a:lstStyle>
-          <a:p>
-            <a:pPr algn="l"/>
-            <a:r>
-              <a:rPr lang="en-US" sz="2000">
-                <a:solidFill>
-                  <a:srgbClr val="FFFFFF"/>
-                </a:solidFill>
-                <a:latin typeface="Encode Sans"/>
-              </a:rPr>
-              <a:t>BDATA 412: Advanced Data Visualization</a:t>
-            </a:r>
-          </a:p>
-          <a:p>
-            <a:pPr algn="l"/>
-            <a:r>
-              <a:rPr lang="en-US" sz="1800">
-                <a:solidFill>
-                  <a:srgbClr val="E8D3FF"/>
-                </a:solidFill>
-                <a:latin typeface="Encode Sans"/>
-              </a:rPr>
-              <a:t>University of Washington</a:t>
-            </a:r>
-          </a:p>
-        </p:txBody>
-      </p:sp>
-      <p:sp>
-        <p:nvSpPr>
-          <p:cNvPr id="5" name="Oval 4">
-            <a:extLst>
-              <a:ext uri="{FF2B5EF4-FFF2-40B4-BE49-F238E27FC236}">
-                <a16:creationId xmlns:a16="http://schemas.microsoft.com/office/drawing/2014/main" id="{7A394970-FCFA-F222-F4ED-8442DB25E364}"/>
-              </a:ext>
-            </a:extLst>
-          </p:cNvPr>
-          <p:cNvSpPr/>
-          <p:nvPr/>
-        </p:nvSpPr>
-        <p:spPr>
-          <a:xfrm>
-            <a:off x="10668000" y="239844"/>
-            <a:ext cx="1379096" cy="1349114"/>
-          </a:xfrm>
-          <a:prstGeom prst="ellipse">
-            <a:avLst/>
-          </a:prstGeom>
-          <a:solidFill>
-            <a:srgbClr val="4B2E83"/>
-          </a:solidFill>
-          <a:ln>
-            <a:noFill/>
-          </a:ln>
-        </p:spPr>
-        <p:style>
-          <a:lnRef idx="1">
-            <a:schemeClr val="accent1"/>
-          </a:lnRef>
-          <a:fillRef idx="3">
-            <a:schemeClr val="accent1"/>
-          </a:fillRef>
-          <a:effectRef idx="2">
-            <a:schemeClr val="accent1"/>
-          </a:effectRef>
-          <a:fontRef idx="minor">
-            <a:schemeClr val="lt1"/>
-          </a:fontRef>
-        </p:style>
-        <p:txBody>
-          <a:bodyPr rtlCol="0" anchor="ctr"/>
-          <a:lstStyle/>
-          <a:p>
-            <a:pPr algn="ctr">
-              <a:defRPr sz="5600" b="1">
-                <a:solidFill>
-                  <a:srgbClr val="FFFFFF"/>
-                </a:solidFill>
-              </a:defRPr>
-            </a:pPr>
-            <a:r>
-              <a:rPr lang="en-US" dirty="0"/>
-              <a:t>6</a:t>
-            </a:r>
-            <a:endParaRPr dirty="0"/>
-          </a:p>
-        </p:txBody>
-      </p:sp>
-    </p:spTree>
-    <p:extLst>
-      <p:ext uri="{BB962C8B-B14F-4D97-AF65-F5344CB8AC3E}">
-        <p14:creationId xmlns:p14="http://schemas.microsoft.com/office/powerpoint/2010/main" val="3502798037"/>
-      </p:ext>
-    </p:extLst>
-  </p:cSld>
-  <p:clrMapOvr>
-    <a:masterClrMapping/>
-  </p:clrMapOvr>
-</p:sld>
 </file>
 
 <file path=ppt/slides/slide10.xml><?xml version="1.0" encoding="utf-8"?>
@@ -49574,44 +49341,109 @@
 </file>
 
 <file path=ppt/slides/slide63.xml><?xml version="1.0" encoding="utf-8"?>
-<p:sld xmlns:a="http://schemas.openxmlformats.org/drawingml/2006/main" xmlns:r="http://schemas.openxmlformats.org/officeDocument/2006/relationships" xmlns:p="http://schemas.openxmlformats.org/presentationml/2006/main">
+<p:sld xmlns:a="http://schemas.openxmlformats.org/drawingml/2006/main" xmlns:p="http://schemas.openxmlformats.org/presentationml/2006/main" xmlns:r="http://schemas.openxmlformats.org/officeDocument/2006/relationships">
   <p:cSld>
-    <p:bg>
-      <p:bgPr>
-        <a:solidFill>
-          <a:srgbClr val="FFFFFF">
-            <a:alpha val="100000"/>
-          </a:srgbClr>
-        </a:solidFill>
-        <a:effectLst/>
-      </p:bgPr>
-    </p:bg>
     <p:spTree>
       <p:nvGrpSpPr>
         <p:cNvPr id="1" name=""/>
         <p:cNvGrpSpPr/>
         <p:nvPr/>
       </p:nvGrpSpPr>
-      <p:grpSpPr>
-        <a:xfrm>
-          <a:off x="0" y="0"/>
-          <a:ext cx="0" cy="0"/>
-          <a:chOff x="0" y="0"/>
-          <a:chExt cx="0" cy="0"/>
-        </a:xfrm>
-      </p:grpSpPr>
-      <p:sp>
-        <p:nvSpPr>
-          <p:cNvPr id="2" name="Accent Bar"/>
+      <p:grpSpPr/>
+      <p:sp>
+        <p:nvSpPr>
+          <p:cNvPr id="2" name="Title 1"/>
+          <p:cNvSpPr>
+            <a:spLocks noGrp="1"/>
+          </p:cNvSpPr>
+          <p:nvPr>
+            <p:ph type="ctrTitle"/>
+          </p:nvPr>
+        </p:nvSpPr>
+        <p:spPr/>
+        <p:txBody>
+          <a:bodyPr/>
+          <a:lstStyle/>
+          <a:p>
+            <a:r>
+              <a:rPr sz="3600" b="1">
+                <a:solidFill>
+                  <a:srgbClr val="4B2E83"/>
+                </a:solidFill>
+                <a:latin typeface="Encode Sans"/>
+              </a:rPr>
+              <a:t>Correspondence Analysis</a:t>
+            </a:r>
+          </a:p>
+          <a:p>
+            <a:r>
+              <a:rPr sz="3600" b="1">
+                <a:solidFill>
+                  <a:srgbClr val="4B2E83"/>
+                </a:solidFill>
+                <a:latin typeface="Encode Sans"/>
+              </a:rPr>
+              <a:t>and MCA</a:t>
+            </a:r>
+          </a:p>
+        </p:txBody>
+      </p:sp>
+      <p:sp>
+        <p:nvSpPr>
+          <p:cNvPr id="3" name="Subtitle 2"/>
+          <p:cNvSpPr>
+            <a:spLocks noGrp="1"/>
+          </p:cNvSpPr>
+          <p:nvPr>
+            <p:ph type="subTitle" idx="1"/>
+          </p:nvPr>
+        </p:nvSpPr>
+        <p:spPr/>
+        <p:txBody>
+          <a:bodyPr/>
+          <a:lstStyle/>
+          <a:p>
+            <a:r>
+              <a:rPr sz="2000">
+                <a:solidFill>
+                  <a:srgbClr val="85754D"/>
+                </a:solidFill>
+                <a:latin typeface="Encode Sans"/>
+              </a:rPr>
+              <a:t>BDATA 412: Advanced Data Visualization</a:t>
+            </a:r>
+          </a:p>
+          <a:p>
+            <a:r>
+              <a:rPr sz="1800">
+                <a:solidFill>
+                  <a:srgbClr val="666666"/>
+                </a:solidFill>
+                <a:latin typeface="Encode Sans"/>
+              </a:rPr>
+              <a:t>University of Washington</a:t>
+            </a:r>
+          </a:p>
+        </p:txBody>
+      </p:sp>
+      <p:sp>
+        <p:nvSpPr>
+          <p:cNvPr id="5" name="Oval 4">
+            <a:extLst>
+              <a:ext uri="{FF2B5EF4-FFF2-40B4-BE49-F238E27FC236}">
+                <a16:creationId xmlns:a16="http://schemas.microsoft.com/office/drawing/2014/main" id="{7A394970-FCFA-F222-F4ED-8442DB25E364}"/>
+              </a:ext>
+            </a:extLst>
+          </p:cNvPr>
           <p:cNvSpPr/>
           <p:nvPr/>
         </p:nvSpPr>
         <p:spPr>
           <a:xfrm>
-            <a:off x="762000" y="584200"/>
-            <a:ext cx="762000" cy="76200"/>
-          </a:xfrm>
-          <a:prstGeom prst="rect">
+            <a:off x="10668000" y="239844"/>
+            <a:ext cx="1379096" cy="1349114"/>
+          </a:xfrm>
+          <a:prstGeom prst="ellipse">
             <a:avLst/>
           </a:prstGeom>
           <a:solidFill>
@@ -49621,581 +49453,194 @@
             <a:noFill/>
           </a:ln>
         </p:spPr>
+        <p:style>
+          <a:lnRef idx="1">
+            <a:schemeClr val="accent1"/>
+          </a:lnRef>
+          <a:fillRef idx="3">
+            <a:schemeClr val="accent1"/>
+          </a:fillRef>
+          <a:effectRef idx="2">
+            <a:schemeClr val="accent1"/>
+          </a:effectRef>
+          <a:fontRef idx="minor">
+            <a:schemeClr val="lt1"/>
+          </a:fontRef>
+        </p:style>
+        <p:txBody>
+          <a:bodyPr rtlCol="0" anchor="ctr"/>
+          <a:lstStyle/>
+          <a:p>
+            <a:pPr algn="ctr">
+              <a:defRPr sz="5600" b="1">
+                <a:solidFill>
+                  <a:srgbClr val="FFFFFF"/>
+                </a:solidFill>
+              </a:defRPr>
+            </a:pPr>
+            <a:r>
+              <a:rPr lang="en-US" dirty="0"/>
+              <a:t>6</a:t>
+            </a:r>
+            <a:endParaRPr dirty="0"/>
+          </a:p>
+        </p:txBody>
+      </p:sp>
+    </p:spTree>
+  </p:cSld>
+  <p:clrMapOvr>
+    <a:masterClrMapping/>
+  </p:clrMapOvr>
+</p:sld>
+</file>
+
+<file path=ppt/slides/slide63.xml><?xml version="1.0" encoding="utf-8"?>
+<p:sld xmlns:a="http://schemas.openxmlformats.org/drawingml/2006/main" xmlns:p="http://schemas.openxmlformats.org/presentationml/2006/main" xmlns:r="http://schemas.openxmlformats.org/officeDocument/2006/relationships">
+  <p:cSld>
+    <p:spTree>
+      <p:nvGrpSpPr>
+        <p:cNvPr id="1" name=""/>
+        <p:cNvGrpSpPr/>
+        <p:nvPr/>
+      </p:nvGrpSpPr>
+      <p:grpSpPr/>
+      <p:sp>
+        <p:nvSpPr>
+          <p:cNvPr id="2" name="Title 1"/>
+          <p:cNvSpPr>
+            <a:spLocks noGrp="1"/>
+          </p:cNvSpPr>
+          <p:nvPr>
+            <p:ph type="ctrTitle"/>
+          </p:nvPr>
+        </p:nvSpPr>
+        <p:spPr/>
         <p:txBody>
           <a:bodyPr/>
           <a:lstStyle/>
           <a:p>
-            <a:endParaRPr/>
-          </a:p>
-        </p:txBody>
-      </p:sp>
-      <p:sp>
-        <p:nvSpPr>
-          <p:cNvPr id="3" name="Title"/>
-          <p:cNvSpPr txBox="1"/>
-          <p:nvPr/>
-        </p:nvSpPr>
-        <p:spPr>
-          <a:xfrm>
-            <a:off x="762000" y="660400"/>
-            <a:ext cx="10668000" cy="508000"/>
-          </a:xfrm>
-          <a:prstGeom prst="rect">
-            <a:avLst/>
-          </a:prstGeom>
-          <a:noFill/>
-          <a:ln>
-            <a:noFill/>
-          </a:ln>
-        </p:spPr>
-        <p:txBody>
-          <a:bodyPr wrap="square" lIns="91440" tIns="45720" rIns="91440" bIns="45720" rtlCol="0" anchor="t">
-            <a:normAutofit/>
-          </a:bodyPr>
-          <a:lstStyle/>
-          <a:p>
-            <a:pPr algn="l"/>
-            <a:r>
-              <a:rPr lang="en-US" sz="2600" b="1" dirty="0">
+            <a:r>
+              <a:rPr sz="3600" b="1">
                 <a:solidFill>
                   <a:srgbClr val="4B2E83"/>
                 </a:solidFill>
-              </a:rPr>
-              <a:t>Example B · Step 6 — SVD &amp; the MCA Map</a:t>
-            </a:r>
-          </a:p>
-        </p:txBody>
-      </p:sp>
-      <p:sp>
-        <p:nvSpPr>
-          <p:cNvPr id="4" name="Subtitle"/>
-          <p:cNvSpPr txBox="1"/>
-          <p:nvPr/>
-        </p:nvSpPr>
-        <p:spPr>
-          <a:xfrm>
-            <a:off x="762000" y="1244600"/>
-            <a:ext cx="10668000" cy="381000"/>
-          </a:xfrm>
-          <a:prstGeom prst="rect">
-            <a:avLst/>
-          </a:prstGeom>
-          <a:noFill/>
-          <a:ln>
-            <a:noFill/>
-          </a:ln>
-        </p:spPr>
-        <p:txBody>
-          <a:bodyPr wrap="square" lIns="91440" tIns="45720" rIns="91440" bIns="45720" rtlCol="0" anchor="t">
-            <a:normAutofit/>
-          </a:bodyPr>
-          <a:lstStyle/>
-          <a:p>
-            <a:pPr algn="l"/>
-            <a:r>
-              <a:rPr lang="en-US" sz="1400" i="1" dirty="0">
-                <a:solidFill>
-                  <a:srgbClr val="333333"/>
-                </a:solidFill>
-              </a:rPr>
-              <a:t>S = U Σ Vᵀ; coordinates G = Dc^(−1/2) V Σ place the five categories.</a:t>
-            </a:r>
-          </a:p>
-        </p:txBody>
-      </p:sp>
-      <p:sp>
-        <p:nvSpPr>
-          <p:cNvPr id="10" name="Left Card"/>
+                <a:latin typeface="Encode Sans"/>
+              </a:rPr>
+              <a:t>Correspondence Analysis</a:t>
+            </a:r>
+          </a:p>
+          <a:p>
+            <a:r>
+              <a:rPr sz="3600" b="1">
+                <a:solidFill>
+                  <a:srgbClr val="4B2E83"/>
+                </a:solidFill>
+                <a:latin typeface="Encode Sans"/>
+              </a:rPr>
+              <a:t>and MCA</a:t>
+            </a:r>
+          </a:p>
+        </p:txBody>
+      </p:sp>
+      <p:sp>
+        <p:nvSpPr>
+          <p:cNvPr id="3" name="Subtitle 2"/>
+          <p:cNvSpPr>
+            <a:spLocks noGrp="1"/>
+          </p:cNvSpPr>
+          <p:nvPr>
+            <p:ph type="subTitle" idx="1"/>
+          </p:nvPr>
+        </p:nvSpPr>
+        <p:spPr/>
+        <p:txBody>
+          <a:bodyPr/>
+          <a:lstStyle/>
+          <a:p>
+            <a:r>
+              <a:rPr sz="2000">
+                <a:solidFill>
+                  <a:srgbClr val="85754D"/>
+                </a:solidFill>
+                <a:latin typeface="Encode Sans"/>
+              </a:rPr>
+              <a:t>BDATA 412: Advanced Data Visualization</a:t>
+            </a:r>
+          </a:p>
+          <a:p>
+            <a:r>
+              <a:rPr sz="1800">
+                <a:solidFill>
+                  <a:srgbClr val="666666"/>
+                </a:solidFill>
+                <a:latin typeface="Encode Sans"/>
+              </a:rPr>
+              <a:t>University of Washington</a:t>
+            </a:r>
+          </a:p>
+        </p:txBody>
+      </p:sp>
+      <p:sp>
+        <p:nvSpPr>
+          <p:cNvPr id="5" name="Oval 4">
+            <a:extLst>
+              <a:ext uri="{FF2B5EF4-FFF2-40B4-BE49-F238E27FC236}">
+                <a16:creationId xmlns:a16="http://schemas.microsoft.com/office/drawing/2014/main" id="{7A394970-FCFA-F222-F4ED-8442DB25E364}"/>
+              </a:ext>
+            </a:extLst>
+          </p:cNvPr>
           <p:cNvSpPr/>
           <p:nvPr/>
         </p:nvSpPr>
         <p:spPr>
           <a:xfrm>
-            <a:off x="762000" y="1905000"/>
-            <a:ext cx="5969000" cy="3810000"/>
-          </a:xfrm>
-          <a:prstGeom prst="roundRect">
+            <a:off x="10668000" y="239844"/>
+            <a:ext cx="1379096" cy="1349114"/>
+          </a:xfrm>
+          <a:prstGeom prst="ellipse">
             <a:avLst/>
           </a:prstGeom>
           <a:solidFill>
-            <a:srgbClr val="F7F4FB"/>
-          </a:solidFill>
-          <a:ln w="15875">
-            <a:solidFill>
-              <a:srgbClr val="4B2E83"/>
-            </a:solidFill>
-          </a:ln>
-        </p:spPr>
-        <p:txBody>
-          <a:bodyPr/>
-          <a:lstStyle/>
-          <a:p>
-            <a:endParaRPr/>
-          </a:p>
-        </p:txBody>
-      </p:sp>
-      <p:sp>
-        <p:nvSpPr>
-          <p:cNvPr id="11" name="Left Label"/>
-          <p:cNvSpPr txBox="1"/>
-          <p:nvPr/>
-        </p:nvSpPr>
-        <p:spPr>
-          <a:xfrm>
-            <a:off x="965200" y="2032000"/>
-            <a:ext cx="5562600" cy="304800"/>
-          </a:xfrm>
-          <a:prstGeom prst="rect">
-            <a:avLst/>
-          </a:prstGeom>
-          <a:noFill/>
-          <a:ln>
-            <a:noFill/>
-          </a:ln>
-        </p:spPr>
-        <p:txBody>
-          <a:bodyPr wrap="square" lIns="91440" tIns="45720" rIns="91440" bIns="45720" rtlCol="0" anchor="t">
-            <a:normAutofit lnSpcReduction="10000"/>
-          </a:bodyPr>
-          <a:lstStyle/>
-          <a:p>
-            <a:pPr algn="l"/>
-            <a:r>
-              <a:rPr lang="en-US" sz="1500" b="1" dirty="0">
-                <a:solidFill>
-                  <a:srgbClr val="4B2E83"/>
-                </a:solidFill>
-              </a:rPr>
-              <a:t>Decompose, then place the points</a:t>
-            </a:r>
-          </a:p>
-        </p:txBody>
-      </p:sp>
-      <mc:AlternateContent xmlns:mc="http://schemas.openxmlformats.org/markup-compatibility/2006">
-        <mc:Choice xmlns:a14="http://schemas.microsoft.com/office/drawing/2010/main" Requires="a14">
-          <p:sp>
-            <p:nvSpPr>
-              <p:cNvPr id="13" name="Equations"/>
-              <p:cNvSpPr txBox="1"/>
-              <p:nvPr/>
-            </p:nvSpPr>
-            <p:spPr>
-              <a:xfrm>
-                <a:off x="635000" y="2438400"/>
-                <a:ext cx="6223000" cy="1651000"/>
-              </a:xfrm>
-              <a:prstGeom prst="rect">
-                <a:avLst/>
-              </a:prstGeom>
-              <a:noFill/>
-              <a:ln>
-                <a:noFill/>
-              </a:ln>
-            </p:spPr>
-            <p:txBody>
-              <a:bodyPr wrap="square" lIns="91440" tIns="45720" rIns="91440" bIns="45720" rtlCol="0" anchor="ctr">
-                <a:normAutofit/>
-              </a:bodyPr>
-              <a:lstStyle/>
-              <a:p>
-                <a:pPr algn="ctr"/>
-                <a14:m>
-                  <m:oMathPara xmlns:m="http://schemas.openxmlformats.org/officeDocument/2006/math">
-                    <m:oMathParaPr>
-                      <m:jc m:val="center"/>
-                    </m:oMathParaPr>
-                    <m:oMath xmlns:m="http://schemas.openxmlformats.org/officeDocument/2006/math">
-                      <m:r>
-                        <a:rPr sz="2160">
-                          <a:latin typeface="Cambria Math"/>
-                        </a:rPr>
-                        <m:t>𝑆</m:t>
-                      </m:r>
-                      <m:r>
-                        <a:rPr sz="2160">
-                          <a:latin typeface="Cambria Math"/>
-                        </a:rPr>
-                        <m:t>=</m:t>
-                      </m:r>
-                      <m:r>
-                        <a:rPr sz="2160">
-                          <a:latin typeface="Cambria Math"/>
-                        </a:rPr>
-                        <m:t>𝑈</m:t>
-                      </m:r>
-                      <m:r>
-                        <a:rPr sz="2160" b="1">
-                          <a:solidFill>
-                            <a:srgbClr val="85754D"/>
-                          </a:solidFill>
-                          <a:latin typeface="Cambria Math"/>
-                        </a:rPr>
-                        <m:t>𝛴</m:t>
-                      </m:r>
-                      <m:sSup>
-                        <m:sSupPr>
-                          <m:ctrlPr>
-                            <a:rPr i="1">
-                              <a:latin typeface="Cambria Math" panose="02040503050406030204" pitchFamily="18" charset="0"/>
-                            </a:rPr>
-                          </m:ctrlPr>
-                        </m:sSupPr>
-                        <m:e>
-                          <m:r>
-                            <a:rPr sz="2160">
-                              <a:latin typeface="Cambria Math"/>
-                            </a:rPr>
-                            <m:t>𝑉</m:t>
-                          </m:r>
-                        </m:e>
-                        <m:sup>
-                          <m:r>
-                            <a:rPr sz="2160">
-                              <a:latin typeface="Cambria Math"/>
-                            </a:rPr>
-                            <m:t>𝑇</m:t>
-                          </m:r>
-                        </m:sup>
-                      </m:sSup>
-                    </m:oMath>
-                  </m:oMathPara>
-                </a14:m>
-                <a:endParaRPr lang="en-US" sz="1600"/>
-              </a:p>
-              <a:p>
-                <a:pPr algn="ctr"/>
-                <a14:m>
-                  <m:oMathPara xmlns:m="http://schemas.openxmlformats.org/officeDocument/2006/math">
-                    <m:oMathParaPr>
-                      <m:jc m:val="center"/>
-                    </m:oMathParaPr>
-                    <m:oMath xmlns:m="http://schemas.openxmlformats.org/officeDocument/2006/math">
-                      <m:r>
-                        <a:rPr sz="2160">
-                          <a:latin typeface="Cambria Math"/>
-                        </a:rPr>
-                        <m:t>𝐺</m:t>
-                      </m:r>
-                      <m:r>
-                        <a:rPr sz="2160">
-                          <a:latin typeface="Cambria Math"/>
-                        </a:rPr>
-                        <m:t>=</m:t>
-                      </m:r>
-                      <m:sSubSup>
-                        <m:sSubSupPr>
-                          <m:ctrlPr>
-                            <a:rPr i="1">
-                              <a:latin typeface="Cambria Math" panose="02040503050406030204" pitchFamily="18" charset="0"/>
-                            </a:rPr>
-                          </m:ctrlPr>
-                        </m:sSubSupPr>
-                        <m:e>
-                          <m:r>
-                            <a:rPr sz="2160">
-                              <a:latin typeface="Cambria Math"/>
-                            </a:rPr>
-                            <m:t>𝐷</m:t>
-                          </m:r>
-                        </m:e>
-                        <m:sub>
-                          <m:r>
-                            <a:rPr sz="2160">
-                              <a:latin typeface="Cambria Math"/>
-                            </a:rPr>
-                            <m:t>𝑐</m:t>
-                          </m:r>
-                        </m:sub>
-                        <m:sup>
-                          <m:r>
-                            <a:rPr sz="2160">
-                              <a:latin typeface="Cambria Math"/>
-                            </a:rPr>
-                            <m:t>−1/2</m:t>
-                          </m:r>
-                        </m:sup>
-                      </m:sSubSup>
-                      <m:r>
-                        <a:rPr sz="2160">
-                          <a:latin typeface="Cambria Math"/>
-                        </a:rPr>
-                        <m:t>𝑉</m:t>
-                      </m:r>
-                      <m:r>
-                        <a:rPr sz="2160" b="1">
-                          <a:solidFill>
-                            <a:srgbClr val="85754D"/>
-                          </a:solidFill>
-                          <a:latin typeface="Cambria Math"/>
-                        </a:rPr>
-                        <m:t>𝛴</m:t>
-                      </m:r>
-                    </m:oMath>
-                  </m:oMathPara>
-                </a14:m>
-                <a:endParaRPr lang="en-US" sz="1600"/>
-              </a:p>
-            </p:txBody>
-          </p:sp>
-        </mc:Choice>
-        <mc:Fallback>
-          <p:sp>
-            <p:nvSpPr>
-              <p:cNvPr id="13" name="Equations"/>
-              <p:cNvSpPr txBox="1">
-                <a:spLocks noRot="1" noChangeAspect="1" noMove="1" noResize="1" noEditPoints="1" noAdjustHandles="1" noChangeArrowheads="1" noChangeShapeType="1" noTextEdit="1"/>
-              </p:cNvSpPr>
-              <p:nvPr/>
-            </p:nvSpPr>
-            <p:spPr>
-              <a:xfrm>
-                <a:off x="635000" y="2438400"/>
-                <a:ext cx="6223000" cy="1651000"/>
-              </a:xfrm>
-              <a:prstGeom prst="rect">
-                <a:avLst/>
-              </a:prstGeom>
-              <a:blipFill>
-                <a:blip r:embed="rId2"/>
-                <a:stretch>
-                  <a:fillRect/>
-                </a:stretch>
-              </a:blipFill>
-              <a:ln>
-                <a:noFill/>
-              </a:ln>
-            </p:spPr>
-            <p:txBody>
-              <a:bodyPr/>
-              <a:lstStyle/>
-              <a:p>
-                <a:r>
-                  <a:rPr lang="en-US">
-                    <a:noFill/>
-                  </a:rPr>
-                  <a:t> </a:t>
-                </a:r>
-              </a:p>
-            </p:txBody>
-          </p:sp>
-        </mc:Fallback>
-      </mc:AlternateContent>
-      <p:sp>
-        <p:nvSpPr>
-          <p:cNvPr id="14" name="Inertia"/>
-          <p:cNvSpPr txBox="1"/>
-          <p:nvPr/>
-        </p:nvSpPr>
-        <p:spPr>
-          <a:xfrm>
-            <a:off x="889000" y="4140200"/>
-            <a:ext cx="5715000" cy="1473200"/>
-          </a:xfrm>
-          <a:prstGeom prst="rect">
-            <a:avLst/>
-          </a:prstGeom>
-          <a:noFill/>
-          <a:ln>
-            <a:noFill/>
-          </a:ln>
-        </p:spPr>
-        <p:txBody>
-          <a:bodyPr wrap="square" lIns="91440" tIns="45720" rIns="91440" bIns="45720" rtlCol="0" anchor="t">
-            <a:normAutofit/>
-          </a:bodyPr>
-          <a:lstStyle/>
-          <a:p>
-            <a:pPr algn="l"/>
-            <a:r>
-              <a:rPr lang="en-US" sz="1350" b="1" dirty="0">
-                <a:solidFill>
-                  <a:srgbClr val="4B2E83"/>
-                </a:solidFill>
-              </a:rPr>
-              <a:t>Axis 1:  λ₁ = σ₁² = 0.91</a:t>
-            </a:r>
-            <a:r>
-              <a:rPr lang="en-US" sz="1300" dirty="0">
-                <a:solidFill>
-                  <a:srgbClr val="85754D"/>
-                </a:solidFill>
-              </a:rPr>
-              <a:t>   (61%)</a:t>
-            </a:r>
-          </a:p>
-          <a:p>
-            <a:pPr algn="l">
-              <a:spcBef>
-                <a:spcPts val="140"/>
-              </a:spcBef>
-            </a:pPr>
-            <a:r>
-              <a:rPr lang="en-US" sz="1350" b="1" dirty="0">
-                <a:solidFill>
-                  <a:srgbClr val="00A7B5"/>
-                </a:solidFill>
-              </a:rPr>
-              <a:t>Axis 2:  λ₂ = σ₂² = 0.50</a:t>
-            </a:r>
-            <a:r>
-              <a:rPr lang="en-US" sz="1300" dirty="0">
-                <a:solidFill>
-                  <a:srgbClr val="85754D"/>
-                </a:solidFill>
-              </a:rPr>
-              <a:t>   (33%)</a:t>
-            </a:r>
-          </a:p>
-          <a:p>
-            <a:pPr algn="l">
-              <a:spcBef>
-                <a:spcPts val="160"/>
-              </a:spcBef>
-            </a:pPr>
-            <a:r>
-              <a:rPr lang="en-US" sz="1250" i="1" dirty="0">
-                <a:solidFill>
-                  <a:srgbClr val="666666"/>
-                </a:solidFill>
-              </a:rPr>
-              <a:t>Total inertia (J−Q)/Q = 1.50</a:t>
-            </a:r>
-          </a:p>
-        </p:txBody>
-      </p:sp>
-      <p:sp>
-        <p:nvSpPr>
-          <p:cNvPr id="20" name="Map Header"/>
-          <p:cNvSpPr txBox="1"/>
-          <p:nvPr/>
-        </p:nvSpPr>
-        <p:spPr>
-          <a:xfrm>
-            <a:off x="6959600" y="1905000"/>
-            <a:ext cx="4495800" cy="304800"/>
-          </a:xfrm>
-          <a:prstGeom prst="rect">
-            <a:avLst/>
-          </a:prstGeom>
-          <a:noFill/>
-          <a:ln>
-            <a:noFill/>
-          </a:ln>
-        </p:spPr>
-        <p:txBody>
-          <a:bodyPr wrap="square" lIns="91440" tIns="45720" rIns="91440" bIns="45720" rtlCol="0" anchor="t">
-            <a:normAutofit/>
-          </a:bodyPr>
-          <a:lstStyle/>
-          <a:p>
-            <a:pPr algn="ctr"/>
-            <a:r>
-              <a:rPr lang="en-US" sz="1400" b="1" dirty="0">
-                <a:solidFill>
-                  <a:srgbClr val="4B2E83"/>
-                </a:solidFill>
-              </a:rPr>
-              <a:t>MCA category map</a:t>
-            </a:r>
-          </a:p>
-        </p:txBody>
-      </p:sp>
-      <p:sp>
-        <p:nvSpPr>
-          <p:cNvPr id="30" name="Takeaway"/>
-          <p:cNvSpPr/>
-          <p:nvPr/>
-        </p:nvSpPr>
-        <p:spPr>
-          <a:xfrm>
-            <a:off x="762000" y="5791200"/>
-            <a:ext cx="10668000" cy="558800"/>
-          </a:xfrm>
-          <a:prstGeom prst="roundRect">
-            <a:avLst/>
-          </a:prstGeom>
-          <a:solidFill>
-            <a:srgbClr val="F5F0EB"/>
+            <a:srgbClr val="4B2E83"/>
           </a:solidFill>
           <a:ln>
             <a:noFill/>
           </a:ln>
         </p:spPr>
-        <p:txBody>
-          <a:bodyPr/>
-          <a:lstStyle/>
-          <a:p>
-            <a:endParaRPr/>
-          </a:p>
-        </p:txBody>
-      </p:sp>
-      <p:sp>
-        <p:nvSpPr>
-          <p:cNvPr id="31" name="Takeaway Text"/>
-          <p:cNvSpPr txBox="1"/>
-          <p:nvPr/>
-        </p:nvSpPr>
-        <p:spPr>
-          <a:xfrm>
-            <a:off x="990600" y="5816600"/>
-            <a:ext cx="10210800" cy="508000"/>
-          </a:xfrm>
-          <a:prstGeom prst="rect">
-            <a:avLst/>
-          </a:prstGeom>
-          <a:noFill/>
-          <a:ln>
-            <a:noFill/>
-          </a:ln>
-        </p:spPr>
-        <p:txBody>
-          <a:bodyPr wrap="square" lIns="91440" tIns="45720" rIns="91440" bIns="45720" rtlCol="0" anchor="ctr">
-            <a:normAutofit/>
-          </a:bodyPr>
-          <a:lstStyle/>
-          <a:p>
-            <a:pPr algn="l"/>
-            <a:r>
-              <a:rPr lang="en-US" sz="1300" b="1" dirty="0">
-                <a:solidFill>
-                  <a:srgbClr val="4B2E83"/>
-                </a:solidFill>
-              </a:rPr>
-              <a:t>Takeaway   </a:t>
-            </a:r>
-            <a:r>
-              <a:rPr lang="en-US" sz="1300" dirty="0">
-                <a:solidFill>
-                  <a:srgbClr val="333333"/>
-                </a:solidFill>
-              </a:rPr>
-              <a:t>Car↔Long and Bike↔Short sit on opposite sides; Train stands apart. Distance on the map = profile dissimilarity.</a:t>
-            </a:r>
-          </a:p>
-        </p:txBody>
-      </p:sp>
-      <p:graphicFrame>
-        <p:nvGraphicFramePr>
-          <p:cNvPr id="40" name="MCA Map B"/>
-          <p:cNvGraphicFramePr/>
-          <p:nvPr/>
-        </p:nvGraphicFramePr>
-        <p:xfrm>
-          <a:off x="6959600" y="2260600"/>
-          <a:ext cx="4495800" cy="3454400"/>
-        </p:xfrm>
-        <a:graphic>
-          <a:graphicData uri="http://schemas.openxmlformats.org/drawingml/2006/chart">
-            <c:chart xmlns:c="http://schemas.openxmlformats.org/drawingml/2006/chart" xmlns:r="http://schemas.openxmlformats.org/officeDocument/2006/relationships" r:id="rId3"/>
-          </a:graphicData>
-        </a:graphic>
-      </p:graphicFrame>
+        <p:style>
+          <a:lnRef idx="1">
+            <a:schemeClr val="accent1"/>
+          </a:lnRef>
+          <a:fillRef idx="3">
+            <a:schemeClr val="accent1"/>
+          </a:fillRef>
+          <a:effectRef idx="2">
+            <a:schemeClr val="accent1"/>
+          </a:effectRef>
+          <a:fontRef idx="minor">
+            <a:schemeClr val="lt1"/>
+          </a:fontRef>
+        </p:style>
+        <p:txBody>
+          <a:bodyPr rtlCol="0" anchor="ctr"/>
+          <a:lstStyle/>
+          <a:p>
+            <a:pPr algn="ctr">
+              <a:defRPr sz="5600" b="1">
+                <a:solidFill>
+                  <a:srgbClr val="FFFFFF"/>
+                </a:solidFill>
+              </a:defRPr>
+            </a:pPr>
+            <a:r>
+              <a:rPr lang="en-US" dirty="0"/>
+              <a:t>6</a:t>
+            </a:r>
+            <a:endParaRPr dirty="0"/>
+          </a:p>
+        </p:txBody>
+      </p:sp>
     </p:spTree>
-    <p:extLst>
-      <p:ext uri="{BB962C8B-B14F-4D97-AF65-F5344CB8AC3E}">
-        <p14:creationId xmlns:p14="http://schemas.microsoft.com/office/powerpoint/2010/main" val="1226134805"/>
-      </p:ext>
-    </p:extLst>
   </p:cSld>
   <p:clrMapOvr>
     <a:masterClrMapping/>

</xml_diff>